<commit_message>
Clarify AI phases and guardrails in v2 deck
Replace the unclear "MVP (internal)" label with the same MVP / Phase 2 /
Phase 3 naming used on the rollout slide, move the data-mapping assistant
to Phase 2, and reword the guardrails so they no longer claim the MVP works
without AI while listing an AI use in the MVP.

Co-Authored-By: Claude Opus 5.5 <noreply@anthropic.com>
Claude-Session: https://claude.ai/code/session_01QgwYR72ZM4NrQnpnnn55bG
</commit_message>
<xml_diff>
--- a/IT Consultant Challenge - Round 1 - Old Men v2.pptx
+++ b/IT Consultant Challenge - Round 1 - Old Men v2.pptx
@@ -12598,7 +12598,7 @@
                           </a:solidFill>
                           <a:latin typeface="IBM Plex Sans"/>
                         </a:rPr>
-                        <a:t>Phase</a:t>
+                        <a:t>When</a:t>
                       </a:r>
                     </a:p>
                   </a:txBody>
@@ -12764,7 +12764,7 @@
                           </a:solidFill>
                           <a:latin typeface="IBM Plex Sans"/>
                         </a:rPr>
-                        <a:t>Suggests how each country’s fields and status codes map to the shared order model</a:t>
+                        <a:t>Helps our engineers connect each new country’s systems to the shared order model</a:t>
                       </a:r>
                     </a:p>
                   </a:txBody>
@@ -12791,7 +12791,7 @@
                           </a:solidFill>
                           <a:latin typeface="IBM Plex Sans"/>
                         </a:rPr>
-                        <a:t>Mapping is the slowest part of each country rollout; engineers approve every mapping</a:t>
+                        <a:t>Every country names its data differently; this is the slowest part of each rollout</a:t>
                       </a:r>
                     </a:p>
                   </a:txBody>
@@ -12812,13 +12812,13 @@
                         </a:lnSpc>
                       </a:pPr>
                       <a:r>
-                        <a:rPr sz="1500" b="1">
+                        <a:rPr sz="1500" b="0">
                           <a:solidFill>
-                            <a:srgbClr val="B8520F"/>
+                            <a:srgbClr val="14213D"/>
                           </a:solidFill>
                           <a:latin typeface="IBM Plex Sans"/>
                         </a:rPr>
-                        <a:t>MVP (internal)</a:t>
+                        <a:t>Phase 2</a:t>
                       </a:r>
                     </a:p>
                   </a:txBody>
@@ -12928,7 +12928,7 @@
                           </a:solidFill>
                           <a:latin typeface="IBM Plex Sans"/>
                         </a:rPr>
-                        <a:t>After pilot</a:t>
+                        <a:t>Phase 3</a:t>
                       </a:r>
                     </a:p>
                   </a:txBody>
@@ -13038,7 +13038,7 @@
                           </a:solidFill>
                           <a:latin typeface="IBM Plex Sans"/>
                         </a:rPr>
-                        <a:t>Later</a:t>
+                        <a:t>Phase 3</a:t>
                       </a:r>
                     </a:p>
                   </a:txBody>
@@ -13148,7 +13148,7 @@
                           </a:solidFill>
                           <a:latin typeface="IBM Plex Sans"/>
                         </a:rPr>
-                        <a:t>Later</a:t>
+                        <a:t>Phase 3</a:t>
                       </a:r>
                     </a:p>
                   </a:txBody>
@@ -13165,13 +13165,53 @@
       </p:graphicFrame>
       <p:sp>
         <p:nvSpPr>
-          <p:cNvPr id="5" name="Rounded Rectangle 4"/>
+          <p:cNvPr id="5" name="TextBox 4"/>
+          <p:cNvSpPr txBox="1"/>
+          <p:nvPr/>
+        </p:nvSpPr>
+        <p:spPr>
+          <a:xfrm>
+            <a:off x="1218895" y="6967728"/>
+            <a:ext cx="15850209" cy="320040"/>
+          </a:xfrm>
+          <a:prstGeom prst="rect">
+            <a:avLst/>
+          </a:prstGeom>
+          <a:noFill/>
+        </p:spPr>
+        <p:txBody>
+          <a:bodyPr wrap="square" lIns="0" rIns="0" tIns="0" bIns="0" anchor="t"/>
+          <a:lstStyle/>
+          <a:p>
+            <a:pPr algn="l">
+              <a:lnSpc>
+                <a:spcPct val="120000"/>
+              </a:lnSpc>
+              <a:spcAft>
+                <a:spcPts val="0"/>
+              </a:spcAft>
+            </a:pPr>
+            <a:r>
+              <a:rPr sz="1400" b="0" i="0">
+                <a:solidFill>
+                  <a:srgbClr val="555E72"/>
+                </a:solidFill>
+                <a:latin typeface="IBM Plex Sans"/>
+              </a:rPr>
+              <a:t>MVP = Sweden pilot, weeks 1–12   ·   Phase 2 = Denmark and Norway   ·   Phase 3 = all markets (see slide 9)</a:t>
+            </a:r>
+          </a:p>
+        </p:txBody>
+      </p:sp>
+      <p:sp>
+        <p:nvSpPr>
+          <p:cNvPr id="6" name="Rounded Rectangle 5"/>
           <p:cNvSpPr/>
           <p:nvPr/>
         </p:nvSpPr>
         <p:spPr>
           <a:xfrm>
-            <a:off x="1218895" y="7360920"/>
+            <a:off x="1218895" y="7406640"/>
             <a:ext cx="15850209" cy="1691640"/>
           </a:xfrm>
           <a:prstGeom prst="roundRect">
@@ -13196,14 +13236,14 @@
       </p:sp>
       <p:sp>
         <p:nvSpPr>
-          <p:cNvPr id="6" name="TextBox 5"/>
-          <p:cNvSpPr txBox="1"/>
-          <p:nvPr/>
-        </p:nvSpPr>
-        <p:spPr>
-          <a:xfrm>
-            <a:off x="1584655" y="7543800"/>
-            <a:ext cx="3657600" cy="365760"/>
+          <p:cNvPr id="7" name="TextBox 6"/>
+          <p:cNvSpPr txBox="1"/>
+          <p:nvPr/>
+        </p:nvSpPr>
+        <p:spPr>
+          <a:xfrm>
+            <a:off x="1584655" y="7571231"/>
+            <a:ext cx="5486400" cy="365760"/>
           </a:xfrm>
           <a:prstGeom prst="rect">
             <a:avLst/>
@@ -13229,21 +13269,21 @@
                 </a:solidFill>
                 <a:latin typeface="IBM Plex Sans"/>
               </a:rPr>
-              <a:t>GUARDRAILS</a:t>
-            </a:r>
-          </a:p>
-        </p:txBody>
-      </p:sp>
-      <p:sp>
-        <p:nvSpPr>
-          <p:cNvPr id="7" name="TextBox 6"/>
+              <a:t>AI ASSISTS, RULES DECIDE</a:t>
+            </a:r>
+          </a:p>
+        </p:txBody>
+      </p:sp>
+      <p:sp>
+        <p:nvSpPr>
+          <p:cNvPr id="8" name="TextBox 7"/>
           <p:cNvSpPr txBox="1"/>
           <p:nvPr/>
         </p:nvSpPr>
         <p:spPr>
           <a:xfrm>
             <a:off x="1584655" y="7955279"/>
-            <a:ext cx="15118689" cy="1005840"/>
+            <a:ext cx="15118689" cy="1097280"/>
           </a:xfrm>
           <a:prstGeom prst="rect">
             <a:avLst/>
@@ -13263,29 +13303,29 @@
               </a:spcAft>
             </a:pPr>
             <a:r>
-              <a:rPr sz="1700" b="1" i="0">
+              <a:rPr sz="1600" b="1" i="0">
                 <a:solidFill>
                   <a:srgbClr val="FFFFFF"/>
                 </a:solidFill>
                 <a:latin typeface="IBM Plex Sans"/>
               </a:rPr>
-              <a:t>The MVP works without AI: </a:t>
-            </a:r>
-            <a:r>
-              <a:rPr sz="1700" b="0" i="0">
+              <a:t>Every alert comes from a clear rule, so staff always see why. </a:t>
+            </a:r>
+            <a:r>
+              <a:rPr sz="1600" b="0" i="0">
                 <a:solidFill>
                   <a:srgbClr val="C9D1E3"/>
                 </a:solidFill>
                 <a:latin typeface="IBM Plex Sans"/>
               </a:rPr>
-              <a:t>the risk checks are plain rules. AI runs on EU-hosted models under GDPR; results with low confidence go to a person. Customer messages use only facts from the order timeline, so AI never invents a delivery date.</a:t>
-            </a:r>
-          </a:p>
-        </p:txBody>
-      </p:sp>
-      <p:sp>
-        <p:nvSpPr>
-          <p:cNvPr id="8" name="TextBox 7"/>
+              <a:t>AI only reads and suggests: dates it is unsure about go to a person, and if AI is down, staff enter dates by hand as today. Customer messages use only facts from the order timeline, so AI never invents a delivery date. Models run in the EU under GDPR.</a:t>
+            </a:r>
+          </a:p>
+        </p:txBody>
+      </p:sp>
+      <p:sp>
+        <p:nvSpPr>
+          <p:cNvPr id="9" name="TextBox 8"/>
           <p:cNvSpPr txBox="1"/>
           <p:nvPr/>
         </p:nvSpPr>
@@ -13325,7 +13365,7 @@
       </p:sp>
       <p:sp>
         <p:nvSpPr>
-          <p:cNvPr id="9" name="TextBox 8"/>
+          <p:cNvPr id="10" name="TextBox 9"/>
           <p:cNvSpPr txBox="1"/>
           <p:nvPr/>
         </p:nvSpPr>
@@ -13724,7 +13764,7 @@
                 </a:solidFill>
                 <a:latin typeface="IBM Plex Sans"/>
               </a:rPr>
-              <a:t>AI: reading supplier messages, data-mapping assistant</a:t>
+              <a:t>AI: reading supplier emails and PDF confirmations</a:t>
             </a:r>
           </a:p>
         </p:txBody>
@@ -13900,7 +13940,7 @@
                 </a:solidFill>
                 <a:latin typeface="IBM Plex Sans"/>
               </a:rPr>
-              <a:t>Denmark and Norway (phase 2)</a:t>
+              <a:t>Denmark and Norway (Phase 2)</a:t>
             </a:r>
           </a:p>
           <a:p>
@@ -13956,7 +13996,7 @@
                 </a:solidFill>
                 <a:latin typeface="IBM Plex Sans"/>
               </a:rPr>
-              <a:t>AI delay prediction (after the pilot)</a:t>
+              <a:t>AI delay prediction (Phase 3)</a:t>
             </a:r>
           </a:p>
         </p:txBody>
@@ -15130,7 +15170,7 @@
                 </a:solidFill>
                 <a:latin typeface="IBM Plex Sans"/>
               </a:rPr>
-              <a:t>New adapters and local settings, store by store. Denmark: less manual chasing. Norway: one way for every store to handle problem orders.</a:t>
+              <a:t>New adapters, built faster with the AI mapping assistant. Denmark: less manual chasing. Norway: one way for every store to handle problem orders.</a:t>
             </a:r>
           </a:p>
         </p:txBody>

</xml_diff>